<commit_message>
Fix two remaining six-model references on the summary and title slides
Co-Authored-By: Claude Opus 5 <noreply@anthropic.com>
</commit_message>
<xml_diff>
--- a/slides/Influenza_Microbiome_ML_Overview.pptx
+++ b/slides/Influenza_Microbiome_ML_Overview.pptx
@@ -3778,7 +3778,7 @@
                 <a:ea typeface="Calibri" pitchFamily="34" charset="-122"/>
                 <a:cs typeface="Calibri" pitchFamily="34" charset="-120"/>
               </a:rPr>
-              <a:t>260 wild ducks  ·  70 microbial features  ·  6 models compared</a:t>
+              <a:t>260 wild ducks  ·  70 microbial features  ·  17 models compared</a:t>
             </a:r>
             <a:endParaRPr lang="en-US" sz="1300" dirty="0"/>
           </a:p>
@@ -23458,7 +23458,7 @@
                 <a:ea typeface="Calibri" pitchFamily="34" charset="-122"/>
                 <a:cs typeface="Calibri" pitchFamily="34" charset="-120"/>
               </a:rPr>
-              <a:t>Nested cross-validation with all preprocessing fitted inside training folds; six models compared on identical splits; three independent feature-ranking methods cross-checked against each other.</a:t>
+              <a:t>Nested cross-validation with all preprocessing fitted inside training folds; seventeen models compared on identical splits; three independent feature-ranking methods cross-checked against each other.</a:t>
             </a:r>
             <a:endParaRPr lang="en-US" sz="1200" dirty="0"/>
           </a:p>

</xml_diff>